<commit_message>
Estrategia 5 de articulacion: elimina hackathones y retos en documento, figura 2 y PPT
</commit_message>
<xml_diff>
--- a/Estrategias-Articulacion-CIE.pptx
+++ b/Estrategias-Articulacion-CIE.pptx
@@ -8879,7 +8879,7 @@
                 </a:solidFill>
                 <a:latin typeface="Century Gothic"/>
               </a:rPr>
-              <a:t>Ferias, retos y hackathones co-organizados con cada facultad.</a:t>
+              <a:t>Ferias, muestras y eventos de emprendimiento co-organizados con cada facultad.</a:t>
             </a:r>
           </a:p>
           <a:p>
@@ -8904,7 +8904,7 @@
                 </a:solidFill>
                 <a:latin typeface="Century Gothic"/>
               </a:rPr>
-              <a:t>Calendario anual; retos temáticos por perfil de facultad.</a:t>
+              <a:t>Calendario anual; actividades según el perfil de cada facultad.</a:t>
             </a:r>
           </a:p>
           <a:p>

</xml_diff>